<commit_message>
Final handover state: research docs, competition artifacts, course materials; drop oversized render/extract caches
</commit_message>
<xml_diff>
--- a/presentation/latent_probing_submission_overview.pptx
+++ b/presentation/latent_probing_submission_overview.pptx
@@ -2103,7 +2103,7 @@
                 <a:ea typeface="Aptos" pitchFamily="34" charset="-122"/>
                 <a:cs typeface="Aptos" pitchFamily="34" charset="-120"/>
               </a:rPr>
-              <a:t>Team Latent Lens</a:t>
+              <a:t>Team nyriagongo</a:t>
             </a:r>
             <a:endParaRPr lang="en-US" sz="1900" dirty="0"/>
           </a:p>
@@ -2343,7 +2343,7 @@
                 <a:ea typeface="Aptos" pitchFamily="34" charset="-122"/>
                 <a:cs typeface="Aptos" pitchFamily="34" charset="-120"/>
               </a:rPr>
-              <a:t>TEAM LATENT LENS   AI SATURDAYS LAGOS, COHORT 10</a:t>
+              <a:t>TEAM NYRIAGONGO   AI SATURDAYS LAGOS, COHORT 10</a:t>
             </a:r>
             <a:endParaRPr lang="en-US" sz="750" dirty="0"/>
           </a:p>
@@ -2953,7 +2953,7 @@
                 <a:ea typeface="Aptos" pitchFamily="34" charset="-122"/>
                 <a:cs typeface="Aptos" pitchFamily="34" charset="-120"/>
               </a:rPr>
-              <a:t>TEAM LATENT LENS   AI SATURDAYS LAGOS, COHORT 10</a:t>
+              <a:t>TEAM NYRIAGONGO   AI SATURDAYS LAGOS, COHORT 10</a:t>
             </a:r>
             <a:endParaRPr lang="en-US" sz="750" dirty="0"/>
           </a:p>
@@ -3850,7 +3850,7 @@
                 <a:ea typeface="Aptos" pitchFamily="34" charset="-122"/>
                 <a:cs typeface="Aptos" pitchFamily="34" charset="-120"/>
               </a:rPr>
-              <a:t>TEAM LATENT LENS   AI SATURDAYS LAGOS, COHORT 10</a:t>
+              <a:t>TEAM NYRIAGONGO   AI SATURDAYS LAGOS, COHORT 10</a:t>
             </a:r>
             <a:endParaRPr lang="en-US" sz="750" dirty="0"/>
           </a:p>
@@ -5043,7 +5043,7 @@
                 <a:ea typeface="Aptos" pitchFamily="34" charset="-122"/>
                 <a:cs typeface="Aptos" pitchFamily="34" charset="-120"/>
               </a:rPr>
-              <a:t>TEAM LATENT LENS   AI SATURDAYS LAGOS, COHORT 10</a:t>
+              <a:t>TEAM NYRIAGONGO   AI SATURDAYS LAGOS, COHORT 10</a:t>
             </a:r>
             <a:endParaRPr lang="en-US" sz="750" dirty="0"/>
           </a:p>
@@ -6895,7 +6895,7 @@
                 <a:ea typeface="Aptos" pitchFamily="34" charset="-122"/>
                 <a:cs typeface="Aptos" pitchFamily="34" charset="-120"/>
               </a:rPr>
-              <a:t>TEAM LATENT LENS   AI SATURDAYS LAGOS, COHORT 10</a:t>
+              <a:t>TEAM NYRIAGONGO   AI SATURDAYS LAGOS, COHORT 10</a:t>
             </a:r>
             <a:endParaRPr lang="en-US" sz="750" dirty="0"/>
           </a:p>
@@ -7461,7 +7461,7 @@
                 <a:ea typeface="Aptos" pitchFamily="34" charset="-122"/>
                 <a:cs typeface="Aptos" pitchFamily="34" charset="-120"/>
               </a:rPr>
-              <a:t>TEAM LATENT LENS   AI SATURDAYS LAGOS, COHORT 10</a:t>
+              <a:t>TEAM NYRIAGONGO   AI SATURDAYS LAGOS, COHORT 10</a:t>
             </a:r>
             <a:endParaRPr lang="en-US" sz="750" dirty="0"/>
           </a:p>
@@ -8149,7 +8149,7 @@
                 <a:ea typeface="Aptos" pitchFamily="34" charset="-122"/>
                 <a:cs typeface="Aptos" pitchFamily="34" charset="-120"/>
               </a:rPr>
-              <a:t>TEAM LATENT LENS   AI SATURDAYS LAGOS, COHORT 10</a:t>
+              <a:t>TEAM NYRIAGONGO   AI SATURDAYS LAGOS, COHORT 10</a:t>
             </a:r>
             <a:endParaRPr lang="en-US" sz="750" dirty="0"/>
           </a:p>
@@ -8882,7 +8882,7 @@
                 <a:ea typeface="Aptos" pitchFamily="34" charset="-122"/>
                 <a:cs typeface="Aptos" pitchFamily="34" charset="-120"/>
               </a:rPr>
-              <a:t>TEAM LATENT LENS   AI SATURDAYS LAGOS, COHORT 10</a:t>
+              <a:t>TEAM NYRIAGONGO   AI SATURDAYS LAGOS, COHORT 10</a:t>
             </a:r>
             <a:endParaRPr lang="en-US" sz="750" dirty="0"/>
           </a:p>
@@ -9106,7 +9106,7 @@
                 <a:ea typeface="Aptos" pitchFamily="34" charset="-122"/>
                 <a:cs typeface="Aptos" pitchFamily="34" charset="-120"/>
               </a:rPr>
-              <a:t>TEAM LATENT LENS</a:t>
+              <a:t>TEAM NYRIAGONGO</a:t>
             </a:r>
             <a:endParaRPr lang="en-US" sz="1000" dirty="0"/>
           </a:p>
@@ -9297,7 +9297,7 @@
                 <a:ea typeface="Aptos" pitchFamily="34" charset="-122"/>
                 <a:cs typeface="Aptos" pitchFamily="34" charset="-120"/>
               </a:rPr>
-              <a:t>Hamna is also in another team. Her Team Latent Lens role covered shared research and Cohort Challenge work and does not imply exclusive membership.</a:t>
+              <a:t>Hamna is also in another team. Her Team nyriagongo role covered shared research and Cohort Challenge work and does not imply exclusive membership.</a:t>
             </a:r>
             <a:endParaRPr lang="en-US" sz="1450" dirty="0"/>
           </a:p>

</xml_diff>